<commit_message>
Remove personal credits from public materials and donation UI from React rebuild
</commit_message>
<xml_diff>
--- a/docs/capstone/poster/Capstone-Poster-Editable.pptx
+++ b/docs/capstone/poster/Capstone-Poster-Editable.pptx
@@ -4,9 +4,6 @@
   <p:sldMasterIdLst>
     <p:sldMasterId id="2147483659" r:id="rId4"/>
   </p:sldMasterIdLst>
-  <p:notesMasterIdLst>
-    <p:notesMasterId r:id="rId5"/>
-  </p:notesMasterIdLst>
   <p:sldIdLst>
     <p:sldId id="256" r:id="rId6"/>
   </p:sldIdLst>
@@ -495,547 +492,6 @@
     </p:ext>
   </p:extLst>
 </p:presentation>
-</file>
-
-<file path=ppt/notesMasters/notesMaster1.xml><?xml version="1.0" encoding="utf-8"?>
-<p:notesMaster xmlns:a="http://schemas.openxmlformats.org/drawingml/2006/main" xmlns:r="http://schemas.openxmlformats.org/officeDocument/2006/relationships" xmlns:mc="http://schemas.openxmlformats.org/markup-compatibility/2006" xmlns:mv="urn:schemas-microsoft-com:mac:vml" xmlns:p="http://schemas.openxmlformats.org/presentationml/2006/main" xmlns:c="http://schemas.openxmlformats.org/drawingml/2006/chart" xmlns:dgm="http://schemas.openxmlformats.org/drawingml/2006/diagram" xmlns:o="urn:schemas-microsoft-com:office:office" xmlns:v="urn:schemas-microsoft-com:vml" xmlns:pvml="urn:schemas-microsoft-com:office:powerpoint" xmlns:com="http://schemas.openxmlformats.org/drawingml/2006/compatibility" xmlns:p14="http://schemas.microsoft.com/office/powerpoint/2010/main" xmlns:p15="http://schemas.microsoft.com/office/powerpoint/2012/main" xmlns:ahyp="http://schemas.microsoft.com/office/drawing/2018/hyperlinkcolor">
-  <p:cSld>
-    <p:spTree>
-      <p:nvGrpSpPr>
-        <p:cNvPr id="2" name="Shape 2"/>
-        <p:cNvGrpSpPr/>
-        <p:nvPr/>
-      </p:nvGrpSpPr>
-      <p:grpSpPr>
-        <a:xfrm>
-          <a:off x="0" y="0"/>
-          <a:ext cx="0" cy="0"/>
-          <a:chOff x="0" y="0"/>
-          <a:chExt cx="0" cy="0"/>
-        </a:xfrm>
-      </p:grpSpPr>
-      <p:sp>
-        <p:nvSpPr>
-          <p:cNvPr id="3" name="Google Shape;3;n"/>
-          <p:cNvSpPr/>
-          <p:nvPr>
-            <p:ph idx="2" type="sldImg"/>
-          </p:nvPr>
-        </p:nvSpPr>
-        <p:spPr>
-          <a:xfrm>
-            <a:off x="875051" y="685800"/>
-            <a:ext cx="5108400" cy="3429000"/>
-          </a:xfrm>
-          <a:custGeom>
-            <a:rect b="b" l="l" r="r" t="t"/>
-            <a:pathLst>
-              <a:path extrusionOk="0" h="120000" w="120000">
-                <a:moveTo>
-                  <a:pt x="0" y="0"/>
-                </a:moveTo>
-                <a:lnTo>
-                  <a:pt x="120000" y="0"/>
-                </a:lnTo>
-                <a:lnTo>
-                  <a:pt x="120000" y="120000"/>
-                </a:lnTo>
-                <a:lnTo>
-                  <a:pt x="0" y="120000"/>
-                </a:lnTo>
-                <a:close/>
-              </a:path>
-            </a:pathLst>
-          </a:custGeom>
-          <a:noFill/>
-          <a:ln cap="flat" cmpd="sng" w="9525">
-            <a:solidFill>
-              <a:srgbClr val="000000"/>
-            </a:solidFill>
-            <a:prstDash val="solid"/>
-            <a:round/>
-            <a:headEnd len="sm" w="sm" type="none"/>
-            <a:tailEnd len="sm" w="sm" type="none"/>
-          </a:ln>
-        </p:spPr>
-      </p:sp>
-      <p:sp>
-        <p:nvSpPr>
-          <p:cNvPr id="4" name="Google Shape;4;n"/>
-          <p:cNvSpPr txBox="1"/>
-          <p:nvPr>
-            <p:ph idx="1" type="body"/>
-          </p:nvPr>
-        </p:nvSpPr>
-        <p:spPr>
-          <a:xfrm>
-            <a:off x="685800" y="4343400"/>
-            <a:ext cx="5486400" cy="4114800"/>
-          </a:xfrm>
-          <a:prstGeom prst="rect">
-            <a:avLst/>
-          </a:prstGeom>
-          <a:noFill/>
-          <a:ln>
-            <a:noFill/>
-          </a:ln>
-        </p:spPr>
-        <p:txBody>
-          <a:bodyPr anchorCtr="0" anchor="t" bIns="91425" lIns="91425" spcFirstLastPara="1" rIns="91425" wrap="square" tIns="91425">
-            <a:noAutofit/>
-          </a:bodyPr>
-          <a:lstStyle>
-            <a:lvl1pPr indent="-298450" lvl="0" marL="457200">
-              <a:spcBef>
-                <a:spcPts val="0"/>
-              </a:spcBef>
-              <a:spcAft>
-                <a:spcPts val="0"/>
-              </a:spcAft>
-              <a:buSzPts val="1100"/>
-              <a:buChar char="●"/>
-              <a:defRPr sz="1100"/>
-            </a:lvl1pPr>
-            <a:lvl2pPr indent="-298450" lvl="1" marL="914400">
-              <a:spcBef>
-                <a:spcPts val="0"/>
-              </a:spcBef>
-              <a:spcAft>
-                <a:spcPts val="0"/>
-              </a:spcAft>
-              <a:buSzPts val="1100"/>
-              <a:buChar char="○"/>
-              <a:defRPr sz="1100"/>
-            </a:lvl2pPr>
-            <a:lvl3pPr indent="-298450" lvl="2" marL="1371600">
-              <a:spcBef>
-                <a:spcPts val="0"/>
-              </a:spcBef>
-              <a:spcAft>
-                <a:spcPts val="0"/>
-              </a:spcAft>
-              <a:buSzPts val="1100"/>
-              <a:buChar char="■"/>
-              <a:defRPr sz="1100"/>
-            </a:lvl3pPr>
-            <a:lvl4pPr indent="-298450" lvl="3" marL="1828800">
-              <a:spcBef>
-                <a:spcPts val="0"/>
-              </a:spcBef>
-              <a:spcAft>
-                <a:spcPts val="0"/>
-              </a:spcAft>
-              <a:buSzPts val="1100"/>
-              <a:buChar char="●"/>
-              <a:defRPr sz="1100"/>
-            </a:lvl4pPr>
-            <a:lvl5pPr indent="-298450" lvl="4" marL="2286000">
-              <a:spcBef>
-                <a:spcPts val="0"/>
-              </a:spcBef>
-              <a:spcAft>
-                <a:spcPts val="0"/>
-              </a:spcAft>
-              <a:buSzPts val="1100"/>
-              <a:buChar char="○"/>
-              <a:defRPr sz="1100"/>
-            </a:lvl5pPr>
-            <a:lvl6pPr indent="-298450" lvl="5" marL="2743200">
-              <a:spcBef>
-                <a:spcPts val="0"/>
-              </a:spcBef>
-              <a:spcAft>
-                <a:spcPts val="0"/>
-              </a:spcAft>
-              <a:buSzPts val="1100"/>
-              <a:buChar char="■"/>
-              <a:defRPr sz="1100"/>
-            </a:lvl6pPr>
-            <a:lvl7pPr indent="-298450" lvl="6" marL="3200400">
-              <a:spcBef>
-                <a:spcPts val="0"/>
-              </a:spcBef>
-              <a:spcAft>
-                <a:spcPts val="0"/>
-              </a:spcAft>
-              <a:buSzPts val="1100"/>
-              <a:buChar char="●"/>
-              <a:defRPr sz="1100"/>
-            </a:lvl7pPr>
-            <a:lvl8pPr indent="-298450" lvl="7" marL="3657600">
-              <a:spcBef>
-                <a:spcPts val="0"/>
-              </a:spcBef>
-              <a:spcAft>
-                <a:spcPts val="0"/>
-              </a:spcAft>
-              <a:buSzPts val="1100"/>
-              <a:buChar char="○"/>
-              <a:defRPr sz="1100"/>
-            </a:lvl8pPr>
-            <a:lvl9pPr indent="-298450" lvl="8" marL="4114800">
-              <a:spcBef>
-                <a:spcPts val="0"/>
-              </a:spcBef>
-              <a:spcAft>
-                <a:spcPts val="0"/>
-              </a:spcAft>
-              <a:buSzPts val="1100"/>
-              <a:buChar char="■"/>
-              <a:defRPr sz="1100"/>
-            </a:lvl9pPr>
-          </a:lstStyle>
-          <a:p/>
-        </p:txBody>
-      </p:sp>
-    </p:spTree>
-  </p:cSld>
-  <p:clrMap accent1="accent1" accent2="accent2" accent3="accent3" accent4="accent4" accent5="accent5" accent6="accent6" bg1="lt1" bg2="dk2" tx1="dk1" tx2="lt2" folHlink="folHlink" hlink="hlink"/>
-  <p:notesStyle>
-    <a:defPPr lvl="0" marR="0" rtl="0" algn="l">
-      <a:lnSpc>
-        <a:spcPct val="100000"/>
-      </a:lnSpc>
-      <a:spcBef>
-        <a:spcPts val="0"/>
-      </a:spcBef>
-      <a:spcAft>
-        <a:spcPts val="0"/>
-      </a:spcAft>
-    </a:defPPr>
-    <a:lvl1pPr lvl="0" marR="0" rtl="0" algn="l">
-      <a:lnSpc>
-        <a:spcPct val="100000"/>
-      </a:lnSpc>
-      <a:spcBef>
-        <a:spcPts val="0"/>
-      </a:spcBef>
-      <a:spcAft>
-        <a:spcPts val="0"/>
-      </a:spcAft>
-      <a:buClr>
-        <a:srgbClr val="000000"/>
-      </a:buClr>
-      <a:buFont typeface="Arial"/>
-      <a:defRPr b="0" i="0" sz="1400" u="none" cap="none" strike="noStrike">
-        <a:solidFill>
-          <a:srgbClr val="000000"/>
-        </a:solidFill>
-        <a:latin typeface="Arial"/>
-        <a:ea typeface="Arial"/>
-        <a:cs typeface="Arial"/>
-        <a:sym typeface="Arial"/>
-      </a:defRPr>
-    </a:lvl1pPr>
-    <a:lvl2pPr lvl="1" marR="0" rtl="0" algn="l">
-      <a:lnSpc>
-        <a:spcPct val="100000"/>
-      </a:lnSpc>
-      <a:spcBef>
-        <a:spcPts val="0"/>
-      </a:spcBef>
-      <a:spcAft>
-        <a:spcPts val="0"/>
-      </a:spcAft>
-      <a:buClr>
-        <a:srgbClr val="000000"/>
-      </a:buClr>
-      <a:buFont typeface="Arial"/>
-      <a:defRPr b="0" i="0" sz="1400" u="none" cap="none" strike="noStrike">
-        <a:solidFill>
-          <a:srgbClr val="000000"/>
-        </a:solidFill>
-        <a:latin typeface="Arial"/>
-        <a:ea typeface="Arial"/>
-        <a:cs typeface="Arial"/>
-        <a:sym typeface="Arial"/>
-      </a:defRPr>
-    </a:lvl2pPr>
-    <a:lvl3pPr lvl="2" marR="0" rtl="0" algn="l">
-      <a:lnSpc>
-        <a:spcPct val="100000"/>
-      </a:lnSpc>
-      <a:spcBef>
-        <a:spcPts val="0"/>
-      </a:spcBef>
-      <a:spcAft>
-        <a:spcPts val="0"/>
-      </a:spcAft>
-      <a:buClr>
-        <a:srgbClr val="000000"/>
-      </a:buClr>
-      <a:buFont typeface="Arial"/>
-      <a:defRPr b="0" i="0" sz="1400" u="none" cap="none" strike="noStrike">
-        <a:solidFill>
-          <a:srgbClr val="000000"/>
-        </a:solidFill>
-        <a:latin typeface="Arial"/>
-        <a:ea typeface="Arial"/>
-        <a:cs typeface="Arial"/>
-        <a:sym typeface="Arial"/>
-      </a:defRPr>
-    </a:lvl3pPr>
-    <a:lvl4pPr lvl="3" marR="0" rtl="0" algn="l">
-      <a:lnSpc>
-        <a:spcPct val="100000"/>
-      </a:lnSpc>
-      <a:spcBef>
-        <a:spcPts val="0"/>
-      </a:spcBef>
-      <a:spcAft>
-        <a:spcPts val="0"/>
-      </a:spcAft>
-      <a:buClr>
-        <a:srgbClr val="000000"/>
-      </a:buClr>
-      <a:buFont typeface="Arial"/>
-      <a:defRPr b="0" i="0" sz="1400" u="none" cap="none" strike="noStrike">
-        <a:solidFill>
-          <a:srgbClr val="000000"/>
-        </a:solidFill>
-        <a:latin typeface="Arial"/>
-        <a:ea typeface="Arial"/>
-        <a:cs typeface="Arial"/>
-        <a:sym typeface="Arial"/>
-      </a:defRPr>
-    </a:lvl4pPr>
-    <a:lvl5pPr lvl="4" marR="0" rtl="0" algn="l">
-      <a:lnSpc>
-        <a:spcPct val="100000"/>
-      </a:lnSpc>
-      <a:spcBef>
-        <a:spcPts val="0"/>
-      </a:spcBef>
-      <a:spcAft>
-        <a:spcPts val="0"/>
-      </a:spcAft>
-      <a:buClr>
-        <a:srgbClr val="000000"/>
-      </a:buClr>
-      <a:buFont typeface="Arial"/>
-      <a:defRPr b="0" i="0" sz="1400" u="none" cap="none" strike="noStrike">
-        <a:solidFill>
-          <a:srgbClr val="000000"/>
-        </a:solidFill>
-        <a:latin typeface="Arial"/>
-        <a:ea typeface="Arial"/>
-        <a:cs typeface="Arial"/>
-        <a:sym typeface="Arial"/>
-      </a:defRPr>
-    </a:lvl5pPr>
-    <a:lvl6pPr lvl="5" marR="0" rtl="0" algn="l">
-      <a:lnSpc>
-        <a:spcPct val="100000"/>
-      </a:lnSpc>
-      <a:spcBef>
-        <a:spcPts val="0"/>
-      </a:spcBef>
-      <a:spcAft>
-        <a:spcPts val="0"/>
-      </a:spcAft>
-      <a:buClr>
-        <a:srgbClr val="000000"/>
-      </a:buClr>
-      <a:buFont typeface="Arial"/>
-      <a:defRPr b="0" i="0" sz="1400" u="none" cap="none" strike="noStrike">
-        <a:solidFill>
-          <a:srgbClr val="000000"/>
-        </a:solidFill>
-        <a:latin typeface="Arial"/>
-        <a:ea typeface="Arial"/>
-        <a:cs typeface="Arial"/>
-        <a:sym typeface="Arial"/>
-      </a:defRPr>
-    </a:lvl6pPr>
-    <a:lvl7pPr lvl="6" marR="0" rtl="0" algn="l">
-      <a:lnSpc>
-        <a:spcPct val="100000"/>
-      </a:lnSpc>
-      <a:spcBef>
-        <a:spcPts val="0"/>
-      </a:spcBef>
-      <a:spcAft>
-        <a:spcPts val="0"/>
-      </a:spcAft>
-      <a:buClr>
-        <a:srgbClr val="000000"/>
-      </a:buClr>
-      <a:buFont typeface="Arial"/>
-      <a:defRPr b="0" i="0" sz="1400" u="none" cap="none" strike="noStrike">
-        <a:solidFill>
-          <a:srgbClr val="000000"/>
-        </a:solidFill>
-        <a:latin typeface="Arial"/>
-        <a:ea typeface="Arial"/>
-        <a:cs typeface="Arial"/>
-        <a:sym typeface="Arial"/>
-      </a:defRPr>
-    </a:lvl7pPr>
-    <a:lvl8pPr lvl="7" marR="0" rtl="0" algn="l">
-      <a:lnSpc>
-        <a:spcPct val="100000"/>
-      </a:lnSpc>
-      <a:spcBef>
-        <a:spcPts val="0"/>
-      </a:spcBef>
-      <a:spcAft>
-        <a:spcPts val="0"/>
-      </a:spcAft>
-      <a:buClr>
-        <a:srgbClr val="000000"/>
-      </a:buClr>
-      <a:buFont typeface="Arial"/>
-      <a:defRPr b="0" i="0" sz="1400" u="none" cap="none" strike="noStrike">
-        <a:solidFill>
-          <a:srgbClr val="000000"/>
-        </a:solidFill>
-        <a:latin typeface="Arial"/>
-        <a:ea typeface="Arial"/>
-        <a:cs typeface="Arial"/>
-        <a:sym typeface="Arial"/>
-      </a:defRPr>
-    </a:lvl8pPr>
-    <a:lvl9pPr lvl="8" marR="0" rtl="0" algn="l">
-      <a:lnSpc>
-        <a:spcPct val="100000"/>
-      </a:lnSpc>
-      <a:spcBef>
-        <a:spcPts val="0"/>
-      </a:spcBef>
-      <a:spcAft>
-        <a:spcPts val="0"/>
-      </a:spcAft>
-      <a:buClr>
-        <a:srgbClr val="000000"/>
-      </a:buClr>
-      <a:buFont typeface="Arial"/>
-      <a:defRPr b="0" i="0" sz="1400" u="none" cap="none" strike="noStrike">
-        <a:solidFill>
-          <a:srgbClr val="000000"/>
-        </a:solidFill>
-        <a:latin typeface="Arial"/>
-        <a:ea typeface="Arial"/>
-        <a:cs typeface="Arial"/>
-        <a:sym typeface="Arial"/>
-      </a:defRPr>
-    </a:lvl9pPr>
-  </p:notesStyle>
-</p:notesMaster>
-</file>
-
-<file path=ppt/notesSlides/notesSlide1.xml><?xml version="1.0" encoding="utf-8"?>
-<p:notes xmlns:a="http://schemas.openxmlformats.org/drawingml/2006/main" xmlns:r="http://schemas.openxmlformats.org/officeDocument/2006/relationships" xmlns:mc="http://schemas.openxmlformats.org/markup-compatibility/2006" xmlns:mv="urn:schemas-microsoft-com:mac:vml" xmlns:p="http://schemas.openxmlformats.org/presentationml/2006/main" xmlns:c="http://schemas.openxmlformats.org/drawingml/2006/chart" xmlns:dgm="http://schemas.openxmlformats.org/drawingml/2006/diagram" xmlns:o="urn:schemas-microsoft-com:office:office" xmlns:v="urn:schemas-microsoft-com:vml" xmlns:pvml="urn:schemas-microsoft-com:office:powerpoint" xmlns:com="http://schemas.openxmlformats.org/drawingml/2006/compatibility" xmlns:p14="http://schemas.microsoft.com/office/powerpoint/2010/main" xmlns:p15="http://schemas.microsoft.com/office/powerpoint/2012/main" xmlns:ahyp="http://schemas.microsoft.com/office/drawing/2018/hyperlinkcolor" showMasterPhAnim="0" showMasterSp="0">
-  <p:cSld>
-    <p:spTree>
-      <p:nvGrpSpPr>
-        <p:cNvPr id="50" name="Shape 50"/>
-        <p:cNvGrpSpPr/>
-        <p:nvPr/>
-      </p:nvGrpSpPr>
-      <p:grpSpPr>
-        <a:xfrm>
-          <a:off x="0" y="0"/>
-          <a:ext cx="0" cy="0"/>
-          <a:chOff x="0" y="0"/>
-          <a:chExt cx="0" cy="0"/>
-        </a:xfrm>
-      </p:grpSpPr>
-      <p:sp>
-        <p:nvSpPr>
-          <p:cNvPr id="51" name="Google Shape;51;g3dedb10067d_0_181:notes"/>
-          <p:cNvSpPr/>
-          <p:nvPr>
-            <p:ph idx="2" type="sldImg"/>
-          </p:nvPr>
-        </p:nvSpPr>
-        <p:spPr>
-          <a:xfrm>
-            <a:off x="875051" y="685800"/>
-            <a:ext cx="5108400" cy="3429000"/>
-          </a:xfrm>
-          <a:custGeom>
-            <a:rect b="b" l="l" r="r" t="t"/>
-            <a:pathLst>
-              <a:path extrusionOk="0" h="120000" w="120000">
-                <a:moveTo>
-                  <a:pt x="0" y="0"/>
-                </a:moveTo>
-                <a:lnTo>
-                  <a:pt x="120000" y="0"/>
-                </a:lnTo>
-                <a:lnTo>
-                  <a:pt x="120000" y="120000"/>
-                </a:lnTo>
-                <a:lnTo>
-                  <a:pt x="0" y="120000"/>
-                </a:lnTo>
-                <a:close/>
-              </a:path>
-            </a:pathLst>
-          </a:custGeom>
-        </p:spPr>
-      </p:sp>
-      <p:sp>
-        <p:nvSpPr>
-          <p:cNvPr id="52" name="Google Shape;52;g3dedb10067d_0_181:notes"/>
-          <p:cNvSpPr txBox="1"/>
-          <p:nvPr>
-            <p:ph idx="1" type="body"/>
-          </p:nvPr>
-        </p:nvSpPr>
-        <p:spPr>
-          <a:xfrm>
-            <a:off x="685800" y="4343400"/>
-            <a:ext cx="5486400" cy="4114800"/>
-          </a:xfrm>
-          <a:prstGeom prst="rect">
-            <a:avLst/>
-          </a:prstGeom>
-        </p:spPr>
-        <p:txBody>
-          <a:bodyPr anchorCtr="0" anchor="t" bIns="91425" lIns="91425" spcFirstLastPara="1" rIns="91425" wrap="square" tIns="91425">
-            <a:noAutofit/>
-          </a:bodyPr>
-          <a:lstStyle/>
-          <a:p>
-            <a:pPr indent="0" lvl="0" marL="0" rtl="0" algn="l">
-              <a:spcBef>
-                <a:spcPts val="0"/>
-              </a:spcBef>
-              <a:spcAft>
-                <a:spcPts val="0"/>
-              </a:spcAft>
-              <a:buNone/>
-            </a:pPr>
-            <a:r>
-              <a:rPr lang="en"/>
-              <a:t>Derek fix centering</a:t>
-            </a:r>
-            <a:endParaRPr/>
-          </a:p>
-          <a:p>
-            <a:pPr indent="0" lvl="0" marL="0" rtl="0" algn="l">
-              <a:spcBef>
-                <a:spcPts val="0"/>
-              </a:spcBef>
-              <a:spcAft>
-                <a:spcPts val="0"/>
-              </a:spcAft>
-              <a:buNone/>
-            </a:pPr>
-            <a:r>
-              <a:t/>
-            </a:r>
-            <a:endParaRPr/>
-          </a:p>
-        </p:txBody>
-      </p:sp>
-    </p:spTree>
-  </p:cSld>
-  <p:clrMapOvr>
-    <a:masterClrMapping/>
-  </p:clrMapOvr>
-</p:notes>
 </file>
 
 <file path=ppt/slideLayouts/slideLayout1.xml><?xml version="1.0" encoding="utf-8"?>
@@ -5921,7 +5377,7 @@
                 <a:cs typeface="Lexend"/>
                 <a:sym typeface="Lexend"/>
               </a:rPr>
-              <a:t>Derek Hodgkins, Caden Kane, Lars Goozen, Zong Xiong</a:t>
+              <a:t/>
             </a:r>
             <a:endParaRPr baseline="30000" sz="3658">
               <a:solidFill>
@@ -5957,7 +5413,7 @@
                 <a:cs typeface="Lexend"/>
                 <a:sym typeface="Lexend"/>
               </a:rPr>
-              <a:t>Project Advisor/Mentor: Sebastian Neumayer</a:t>
+              <a:t/>
             </a:r>
             <a:endParaRPr baseline="30000" sz="3658">
               <a:solidFill>
@@ -7740,7 +7196,7 @@
                 <a:cs typeface="Lexend"/>
                 <a:sym typeface="Lexend"/>
               </a:rPr>
-              <a:t>S. Nakamoto, “Bitcoin: A Peer-to-Peer Electronic Cash System,” 2008. [Online]. Available: </a:t>
+              <a:t>“Bitcoin: A Peer-to-Peer Electronic Cash System,” 2008. [Online]. Available: </a:t>
             </a:r>
             <a:r>
               <a:rPr lang="en" sz="1632" u="sng">
@@ -7785,7 +7241,7 @@
                 <a:cs typeface="Lexend"/>
                 <a:sym typeface="Lexend"/>
               </a:rPr>
-              <a:t>S. Neumayer, M. Varia, and I. Eyal, “An analysis of acceptance policies for blockchain transactions,” IACR Cryptology ePrint Archive, Rep. 2018/040, Jan. 2018. [Online]. Available: </a:t>
+              <a:t>“An analysis of acceptance policies for blockchain transactions,” IACR Cryptology ePrint Archive, Rep. 2018/040, Jan. 2018. [Online]. Available: </a:t>
             </a:r>
             <a:r>
               <a:rPr lang="en" sz="1632" u="sng">

</xml_diff>